<commit_message>
vault backup: 2026-09-17 14:50:27
</commit_message>
<xml_diff>
--- a/content/01_Projects/파이널프로젝트/위솝실무미팅_제안서_20260915_이혜원.pptx
+++ b/content/01_Projects/파이널프로젝트/위솝실무미팅_제안서_20260915_이혜원.pptx
@@ -1256,7 +1256,7 @@
               <a:buNone/>
             </a:pPr>
             <a:r>
-              <a:rPr lang="en-US" sz="3800" b="1" dirty="0">
+              <a:rPr lang="ko-KR" altLang="en-US" sz="3800" b="1" dirty="0">
                 <a:solidFill>
                   <a:srgbClr val="245251"/>
                 </a:solidFill>
@@ -1264,7 +1264,18 @@
                 <a:ea typeface="Cambria" pitchFamily="34" charset="-122"/>
                 <a:cs typeface="Cambria" pitchFamily="34" charset="-120"/>
               </a:rPr>
-              <a:t>퇴근 1시간 뒤,</a:t>
+              <a:t>근무종료</a:t>
+            </a:r>
+            <a:r>
+              <a:rPr lang="en-US" sz="3800" b="1" dirty="0">
+                <a:solidFill>
+                  <a:srgbClr val="245251"/>
+                </a:solidFill>
+                <a:latin typeface="Cambria" pitchFamily="34" charset="0"/>
+                <a:ea typeface="Cambria" pitchFamily="34" charset="-122"/>
+                <a:cs typeface="Cambria" pitchFamily="34" charset="-120"/>
+              </a:rPr>
+              <a:t> 1시간 뒤,</a:t>
             </a:r>
             <a:endParaRPr lang="en-US" sz="3800" dirty="0"/>
           </a:p>
@@ -1368,7 +1379,7 @@
         <p:spPr>
           <a:xfrm>
             <a:off x="822959" y="4526280"/>
-            <a:ext cx="10583793" cy="640080"/>
+            <a:ext cx="10583793" cy="900000"/>
           </a:xfrm>
           <a:prstGeom prst="rect">
             <a:avLst/>
@@ -1386,6 +1397,25 @@
               </a:lnSpc>
             </a:pPr>
             <a:r>
+              <a:rPr lang="ko-KR" altLang="en-US" sz="1500" b="1" dirty="0">
+                <a:solidFill>
+                  <a:srgbClr val="4A4E5A"/>
+                </a:solidFill>
+                <a:latin typeface="Calibri" pitchFamily="34" charset="0"/>
+                <a:ea typeface="Calibri" pitchFamily="34" charset="-122"/>
+                <a:cs typeface="Calibri" pitchFamily="34" charset="-120"/>
+              </a:rPr>
+              <a:t>N잡러와 매장을 잇는 서비스입니다.</a:t>
+            </a:r>
+            <a:endParaRPr lang="en-US" sz="1500" b="1" dirty="0"/>
+          </a:p>
+          <a:p>
+            <a:pPr>
+              <a:lnSpc>
+                <a:spcPct val="130000"/>
+              </a:lnSpc>
+            </a:pPr>
+            <a:r>
               <a:rPr lang="ko-KR" altLang="en-US" sz="1500" dirty="0">
                 <a:solidFill>
                   <a:srgbClr val="4A4E5A"/>
@@ -1394,194 +1424,7 @@
                 <a:ea typeface="Calibri" pitchFamily="34" charset="-122"/>
                 <a:cs typeface="Calibri" pitchFamily="34" charset="-120"/>
               </a:rPr>
-              <a:t> </a:t>
-            </a:r>
-            <a:r>
-              <a:rPr lang="en-US" altLang="ko-KR" sz="1500" dirty="0">
-                <a:solidFill>
-                  <a:srgbClr val="4A4E5A"/>
-                </a:solidFill>
-                <a:latin typeface="Calibri" pitchFamily="34" charset="0"/>
-                <a:ea typeface="Calibri" pitchFamily="34" charset="-122"/>
-                <a:cs typeface="Calibri" pitchFamily="34" charset="-120"/>
-              </a:rPr>
-              <a:t>“</a:t>
-            </a:r>
-            <a:r>
-              <a:rPr lang="ko-KR" altLang="en-US" sz="1500" dirty="0" err="1">
-                <a:solidFill>
-                  <a:srgbClr val="4A4E5A"/>
-                </a:solidFill>
-                <a:latin typeface="Calibri" pitchFamily="34" charset="0"/>
-                <a:ea typeface="Calibri" pitchFamily="34" charset="-122"/>
-                <a:cs typeface="Calibri" pitchFamily="34" charset="-120"/>
-              </a:rPr>
-              <a:t>그때그때되는</a:t>
-            </a:r>
-            <a:r>
-              <a:rPr lang="ko-KR" altLang="en-US" sz="1500" dirty="0">
-                <a:solidFill>
-                  <a:srgbClr val="4A4E5A"/>
-                </a:solidFill>
-                <a:latin typeface="Calibri" pitchFamily="34" charset="0"/>
-                <a:ea typeface="Calibri" pitchFamily="34" charset="-122"/>
-                <a:cs typeface="Calibri" pitchFamily="34" charset="-120"/>
-              </a:rPr>
-              <a:t> 시간</a:t>
-            </a:r>
-            <a:r>
-              <a:rPr lang="en-US" altLang="ko-KR" sz="1500" dirty="0">
-                <a:solidFill>
-                  <a:srgbClr val="4A4E5A"/>
-                </a:solidFill>
-                <a:latin typeface="Calibri" pitchFamily="34" charset="0"/>
-                <a:ea typeface="Calibri" pitchFamily="34" charset="-122"/>
-                <a:cs typeface="Calibri" pitchFamily="34" charset="-120"/>
-              </a:rPr>
-              <a:t>”</a:t>
-            </a:r>
-            <a:r>
-              <a:rPr lang="ko-KR" altLang="en-US" sz="1500" dirty="0">
-                <a:solidFill>
-                  <a:srgbClr val="4A4E5A"/>
-                </a:solidFill>
-                <a:latin typeface="Calibri" pitchFamily="34" charset="0"/>
-                <a:ea typeface="Calibri" pitchFamily="34" charset="-122"/>
-                <a:cs typeface="Calibri" pitchFamily="34" charset="-120"/>
-              </a:rPr>
-              <a:t>을 활용해서 현금지금을 받고자 하는 니즈를 충족시키고자 </a:t>
-            </a:r>
-            <a:r>
-              <a:rPr lang="en-US" sz="1500" dirty="0" err="1">
-                <a:solidFill>
-                  <a:srgbClr val="4A4E5A"/>
-                </a:solidFill>
-                <a:latin typeface="Calibri" pitchFamily="34" charset="0"/>
-                <a:ea typeface="Calibri" pitchFamily="34" charset="-122"/>
-                <a:cs typeface="Calibri" pitchFamily="34" charset="-120"/>
-              </a:rPr>
-              <a:t>N잡러</a:t>
-            </a:r>
-            <a:r>
-              <a:rPr lang="ko-KR" altLang="en-US" sz="1500" dirty="0">
-                <a:solidFill>
-                  <a:srgbClr val="4A4E5A"/>
-                </a:solidFill>
-                <a:latin typeface="Calibri" pitchFamily="34" charset="0"/>
-                <a:ea typeface="Calibri" pitchFamily="34" charset="-122"/>
-                <a:cs typeface="Calibri" pitchFamily="34" charset="-120"/>
-              </a:rPr>
-              <a:t>의 </a:t>
-            </a:r>
-            <a:r>
-              <a:rPr lang="en-US" altLang="ko-KR" sz="1500" dirty="0">
-                <a:solidFill>
-                  <a:srgbClr val="4A4E5A"/>
-                </a:solidFill>
-                <a:latin typeface="Calibri" pitchFamily="34" charset="0"/>
-                <a:ea typeface="Calibri" pitchFamily="34" charset="-122"/>
-                <a:cs typeface="Calibri" pitchFamily="34" charset="-120"/>
-              </a:rPr>
-              <a:t>“</a:t>
-            </a:r>
-            <a:r>
-              <a:rPr lang="ko-KR" altLang="en-US" sz="1500" dirty="0">
-                <a:solidFill>
-                  <a:srgbClr val="4A4E5A"/>
-                </a:solidFill>
-                <a:latin typeface="Calibri" pitchFamily="34" charset="0"/>
-                <a:ea typeface="Calibri" pitchFamily="34" charset="-122"/>
-                <a:cs typeface="Calibri" pitchFamily="34" charset="-120"/>
-              </a:rPr>
-              <a:t>그때그때 비는 시간</a:t>
-            </a:r>
-            <a:r>
-              <a:rPr lang="en-US" altLang="ko-KR" sz="1500" dirty="0">
-                <a:solidFill>
-                  <a:srgbClr val="4A4E5A"/>
-                </a:solidFill>
-                <a:latin typeface="Calibri" pitchFamily="34" charset="0"/>
-                <a:ea typeface="Calibri" pitchFamily="34" charset="-122"/>
-                <a:cs typeface="Calibri" pitchFamily="34" charset="-120"/>
-              </a:rPr>
-              <a:t>＂</a:t>
-            </a:r>
-            <a:r>
-              <a:rPr lang="ko-KR" altLang="en-US" sz="1500" dirty="0">
-                <a:solidFill>
-                  <a:srgbClr val="4A4E5A"/>
-                </a:solidFill>
-                <a:latin typeface="Calibri" pitchFamily="34" charset="0"/>
-                <a:ea typeface="Calibri" pitchFamily="34" charset="-122"/>
-                <a:cs typeface="Calibri" pitchFamily="34" charset="-120"/>
-              </a:rPr>
-              <a:t>과 </a:t>
-            </a:r>
-            <a:r>
-              <a:rPr lang="en-US" sz="1500" dirty="0" err="1">
-                <a:solidFill>
-                  <a:srgbClr val="4A4E5A"/>
-                </a:solidFill>
-                <a:latin typeface="Calibri" pitchFamily="34" charset="0"/>
-                <a:ea typeface="Calibri" pitchFamily="34" charset="-122"/>
-                <a:cs typeface="Calibri" pitchFamily="34" charset="-120"/>
-              </a:rPr>
-              <a:t>일감을</a:t>
-            </a:r>
-            <a:r>
-              <a:rPr lang="en-US" sz="1500" dirty="0">
-                <a:solidFill>
-                  <a:srgbClr val="4A4E5A"/>
-                </a:solidFill>
-                <a:latin typeface="Calibri" pitchFamily="34" charset="0"/>
-                <a:ea typeface="Calibri" pitchFamily="34" charset="-122"/>
-                <a:cs typeface="Calibri" pitchFamily="34" charset="-120"/>
-              </a:rPr>
-              <a:t> 잇는 서비스로 </a:t>
-            </a:r>
-            <a:r>
-              <a:rPr lang="en-US" sz="1500" dirty="0" err="1">
-                <a:solidFill>
-                  <a:srgbClr val="4A4E5A"/>
-                </a:solidFill>
-                <a:latin typeface="Calibri" pitchFamily="34" charset="0"/>
-                <a:ea typeface="Calibri" pitchFamily="34" charset="-122"/>
-                <a:cs typeface="Calibri" pitchFamily="34" charset="-120"/>
-              </a:rPr>
-              <a:t>구체화한</a:t>
-            </a:r>
-            <a:r>
-              <a:rPr lang="en-US" sz="1500" dirty="0">
-                <a:solidFill>
-                  <a:srgbClr val="4A4E5A"/>
-                </a:solidFill>
-                <a:latin typeface="Calibri" pitchFamily="34" charset="0"/>
-                <a:ea typeface="Calibri" pitchFamily="34" charset="-122"/>
-                <a:cs typeface="Calibri" pitchFamily="34" charset="-120"/>
-              </a:rPr>
-              <a:t>  </a:t>
-            </a:r>
-            <a:r>
-              <a:rPr lang="ko-KR" altLang="en-US" sz="1500" dirty="0">
-                <a:solidFill>
-                  <a:srgbClr val="4A4E5A"/>
-                </a:solidFill>
-                <a:latin typeface="Calibri" pitchFamily="34" charset="0"/>
-                <a:ea typeface="Calibri" pitchFamily="34" charset="-122"/>
-                <a:cs typeface="Calibri" pitchFamily="34" charset="-120"/>
-              </a:rPr>
-              <a:t>제안입니다</a:t>
-            </a:r>
-            <a:r>
-              <a:rPr lang="en-US" altLang="ko-KR" sz="1500" dirty="0">
-                <a:solidFill>
-                  <a:srgbClr val="4A4E5A"/>
-                </a:solidFill>
-                <a:latin typeface="Calibri" pitchFamily="34" charset="0"/>
-                <a:ea typeface="Calibri" pitchFamily="34" charset="-122"/>
-                <a:cs typeface="Calibri" pitchFamily="34" charset="-120"/>
-              </a:rPr>
-              <a:t>.</a:t>
+              <a:t>비는 시간에 잠깐 일하고, 근무 종료 즉시 급여를 받거나 하루 근무에 대한 정확한 지급일을 미리 알 수 있는 서비스입니다.</a:t>
             </a:r>
             <a:endParaRPr lang="en-US" sz="1500" dirty="0"/>
           </a:p>
@@ -2900,6 +2743,39 @@
               <a:buNone/>
             </a:pPr>
             <a:r>
+              <a:rPr lang="en-US" sz="1200" dirty="0" err="1">
+                <a:solidFill>
+                  <a:srgbClr val="4A4E5A"/>
+                </a:solidFill>
+                <a:latin typeface="Calibri" pitchFamily="34" charset="0"/>
+                <a:ea typeface="Calibri" pitchFamily="34" charset="-122"/>
+                <a:cs typeface="Calibri" pitchFamily="34" charset="-120"/>
+              </a:rPr>
+              <a:t>급구</a:t>
+            </a:r>
+            <a:r>
+              <a:rPr lang="ko-KR" altLang="en-US" sz="1200" dirty="0">
+                <a:solidFill>
+                  <a:srgbClr val="4A4E5A"/>
+                </a:solidFill>
+                <a:latin typeface="Calibri" pitchFamily="34" charset="0"/>
+                <a:ea typeface="Calibri" pitchFamily="34" charset="-122"/>
+                <a:cs typeface="Calibri" pitchFamily="34" charset="-120"/>
+              </a:rPr>
+              <a:t>러 </a:t>
+            </a:r>
+            <a:r>
+              <a:rPr lang="en-US" altLang="ko-KR" sz="1200" dirty="0">
+                <a:solidFill>
+                  <a:srgbClr val="4A4E5A"/>
+                </a:solidFill>
+                <a:latin typeface="Calibri" pitchFamily="34" charset="0"/>
+                <a:ea typeface="Calibri" pitchFamily="34" charset="-122"/>
+                <a:cs typeface="Calibri" pitchFamily="34" charset="-120"/>
+              </a:rPr>
+              <a:t>4</a:t>
+            </a:r>
+            <a:r>
               <a:rPr lang="en-US" sz="1200" dirty="0">
                 <a:solidFill>
                   <a:srgbClr val="4A4E5A"/>
@@ -2908,7 +2784,238 @@
                 <a:ea typeface="Calibri" pitchFamily="34" charset="-122"/>
                 <a:cs typeface="Calibri" pitchFamily="34" charset="-120"/>
               </a:rPr>
-              <a:t>급구 경험 6명 · 당근 경험 2명 · N잡 관심 낮은 정기 알바 이용자 2명 · 과거 N잡 경험자 1명 · 급구 비경험자 1명, 총 12명을 대상으로 진행했습니다.</a:t>
+              <a:t>명 · </a:t>
+            </a:r>
+            <a:r>
+              <a:rPr lang="en-US" sz="1200" dirty="0" err="1">
+                <a:solidFill>
+                  <a:srgbClr val="4A4E5A"/>
+                </a:solidFill>
+                <a:latin typeface="Calibri" pitchFamily="34" charset="0"/>
+                <a:ea typeface="Calibri" pitchFamily="34" charset="-122"/>
+                <a:cs typeface="Calibri" pitchFamily="34" charset="-120"/>
+              </a:rPr>
+              <a:t>당근</a:t>
+            </a:r>
+            <a:r>
+              <a:rPr lang="ko-KR" altLang="en-US" sz="1200" dirty="0">
+                <a:solidFill>
+                  <a:srgbClr val="4A4E5A"/>
+                </a:solidFill>
+                <a:latin typeface="Calibri" pitchFamily="34" charset="0"/>
+                <a:ea typeface="Calibri" pitchFamily="34" charset="-122"/>
+                <a:cs typeface="Calibri" pitchFamily="34" charset="-120"/>
+              </a:rPr>
+              <a:t>러</a:t>
+            </a:r>
+            <a:r>
+              <a:rPr lang="en-US" sz="1200" dirty="0">
+                <a:solidFill>
+                  <a:srgbClr val="4A4E5A"/>
+                </a:solidFill>
+                <a:latin typeface="Calibri" pitchFamily="34" charset="0"/>
+                <a:ea typeface="Calibri" pitchFamily="34" charset="-122"/>
+                <a:cs typeface="Calibri" pitchFamily="34" charset="-120"/>
+              </a:rPr>
+              <a:t> 3명 · </a:t>
+            </a:r>
+            <a:r>
+              <a:rPr lang="ko-KR" altLang="en-US" sz="1200" dirty="0">
+                <a:solidFill>
+                  <a:srgbClr val="4A4E5A"/>
+                </a:solidFill>
+                <a:latin typeface="Calibri" pitchFamily="34" charset="0"/>
+                <a:ea typeface="Calibri" pitchFamily="34" charset="-122"/>
+                <a:cs typeface="Calibri" pitchFamily="34" charset="-120"/>
+              </a:rPr>
+              <a:t>단기</a:t>
+            </a:r>
+            <a:r>
+              <a:rPr lang="en-US" sz="1200" dirty="0" err="1">
+                <a:solidFill>
+                  <a:srgbClr val="4A4E5A"/>
+                </a:solidFill>
+                <a:latin typeface="Calibri" pitchFamily="34" charset="0"/>
+                <a:ea typeface="Calibri" pitchFamily="34" charset="-122"/>
+                <a:cs typeface="Calibri" pitchFamily="34" charset="-120"/>
+              </a:rPr>
+              <a:t>N잡</a:t>
+            </a:r>
+            <a:r>
+              <a:rPr lang="en-US" sz="1200" dirty="0">
+                <a:solidFill>
+                  <a:srgbClr val="4A4E5A"/>
+                </a:solidFill>
+                <a:latin typeface="Calibri" pitchFamily="34" charset="0"/>
+                <a:ea typeface="Calibri" pitchFamily="34" charset="-122"/>
+                <a:cs typeface="Calibri" pitchFamily="34" charset="-120"/>
+              </a:rPr>
+              <a:t> 관심 낮은 정기 </a:t>
+            </a:r>
+            <a:r>
+              <a:rPr lang="en-US" sz="1200" dirty="0" err="1">
+                <a:solidFill>
+                  <a:srgbClr val="4A4E5A"/>
+                </a:solidFill>
+                <a:latin typeface="Calibri" pitchFamily="34" charset="0"/>
+                <a:ea typeface="Calibri" pitchFamily="34" charset="-122"/>
+                <a:cs typeface="Calibri" pitchFamily="34" charset="-120"/>
+              </a:rPr>
+              <a:t>알바</a:t>
+            </a:r>
+            <a:r>
+              <a:rPr lang="en-US" sz="1200" dirty="0">
+                <a:solidFill>
+                  <a:srgbClr val="4A4E5A"/>
+                </a:solidFill>
+                <a:latin typeface="Calibri" pitchFamily="34" charset="0"/>
+                <a:ea typeface="Calibri" pitchFamily="34" charset="-122"/>
+                <a:cs typeface="Calibri" pitchFamily="34" charset="-120"/>
+              </a:rPr>
+              <a:t> </a:t>
+            </a:r>
+            <a:r>
+              <a:rPr lang="en-US" sz="1200" dirty="0" err="1">
+                <a:solidFill>
+                  <a:srgbClr val="4A4E5A"/>
+                </a:solidFill>
+                <a:latin typeface="Calibri" pitchFamily="34" charset="0"/>
+                <a:ea typeface="Calibri" pitchFamily="34" charset="-122"/>
+                <a:cs typeface="Calibri" pitchFamily="34" charset="-120"/>
+              </a:rPr>
+              <a:t>이용자</a:t>
+            </a:r>
+            <a:r>
+              <a:rPr lang="en-US" sz="1200" dirty="0">
+                <a:solidFill>
+                  <a:srgbClr val="4A4E5A"/>
+                </a:solidFill>
+                <a:latin typeface="Calibri" pitchFamily="34" charset="0"/>
+                <a:ea typeface="Calibri" pitchFamily="34" charset="-122"/>
+                <a:cs typeface="Calibri" pitchFamily="34" charset="-120"/>
+              </a:rPr>
+              <a:t>(</a:t>
+            </a:r>
+            <a:r>
+              <a:rPr lang="ko-KR" altLang="en-US" sz="1200" dirty="0" err="1">
+                <a:solidFill>
+                  <a:srgbClr val="4A4E5A"/>
+                </a:solidFill>
+                <a:latin typeface="Calibri" pitchFamily="34" charset="0"/>
+                <a:ea typeface="Calibri" pitchFamily="34" charset="-122"/>
+                <a:cs typeface="Calibri" pitchFamily="34" charset="-120"/>
+              </a:rPr>
+              <a:t>알바몬</a:t>
+            </a:r>
+            <a:r>
+              <a:rPr lang="en-US" altLang="ko-KR" sz="1200" dirty="0">
+                <a:solidFill>
+                  <a:srgbClr val="4A4E5A"/>
+                </a:solidFill>
+                <a:latin typeface="Calibri" pitchFamily="34" charset="0"/>
+                <a:ea typeface="Calibri" pitchFamily="34" charset="-122"/>
+                <a:cs typeface="Calibri" pitchFamily="34" charset="-120"/>
+              </a:rPr>
+              <a:t>)</a:t>
+            </a:r>
+            <a:r>
+              <a:rPr lang="en-US" sz="1200" dirty="0">
+                <a:solidFill>
+                  <a:srgbClr val="4A4E5A"/>
+                </a:solidFill>
+                <a:latin typeface="Calibri" pitchFamily="34" charset="0"/>
+                <a:ea typeface="Calibri" pitchFamily="34" charset="-122"/>
+                <a:cs typeface="Calibri" pitchFamily="34" charset="-120"/>
+              </a:rPr>
+              <a:t> 1명 · 과거 N잡 </a:t>
+            </a:r>
+            <a:r>
+              <a:rPr lang="en-US" sz="1200" dirty="0" err="1">
+                <a:solidFill>
+                  <a:srgbClr val="4A4E5A"/>
+                </a:solidFill>
+                <a:latin typeface="Calibri" pitchFamily="34" charset="0"/>
+                <a:ea typeface="Calibri" pitchFamily="34" charset="-122"/>
+                <a:cs typeface="Calibri" pitchFamily="34" charset="-120"/>
+              </a:rPr>
+              <a:t>경험자</a:t>
+            </a:r>
+            <a:r>
+              <a:rPr lang="en-US" sz="1200" dirty="0">
+                <a:solidFill>
+                  <a:srgbClr val="4A4E5A"/>
+                </a:solidFill>
+                <a:latin typeface="Calibri" pitchFamily="34" charset="0"/>
+                <a:ea typeface="Calibri" pitchFamily="34" charset="-122"/>
+                <a:cs typeface="Calibri" pitchFamily="34" charset="-120"/>
+              </a:rPr>
+              <a:t> 1명 ·, N</a:t>
+            </a:r>
+            <a:r>
+              <a:rPr lang="ko-KR" altLang="en-US" sz="1200" dirty="0" err="1">
+                <a:solidFill>
+                  <a:srgbClr val="4A4E5A"/>
+                </a:solidFill>
+                <a:latin typeface="Calibri" pitchFamily="34" charset="0"/>
+                <a:ea typeface="Calibri" pitchFamily="34" charset="-122"/>
+                <a:cs typeface="Calibri" pitchFamily="34" charset="-120"/>
+              </a:rPr>
+              <a:t>잡</a:t>
+            </a:r>
+            <a:r>
+              <a:rPr lang="ko-KR" altLang="en-US" sz="1200" dirty="0">
+                <a:solidFill>
+                  <a:srgbClr val="4A4E5A"/>
+                </a:solidFill>
+                <a:latin typeface="Calibri" pitchFamily="34" charset="0"/>
+                <a:ea typeface="Calibri" pitchFamily="34" charset="-122"/>
+                <a:cs typeface="Calibri" pitchFamily="34" charset="-120"/>
+              </a:rPr>
+              <a:t> 관심이 낮은 </a:t>
+            </a:r>
+            <a:r>
+              <a:rPr lang="en-US" altLang="ko-KR" sz="1200" dirty="0">
+                <a:solidFill>
+                  <a:srgbClr val="4A4E5A"/>
+                </a:solidFill>
+                <a:latin typeface="Calibri" pitchFamily="34" charset="0"/>
+                <a:ea typeface="Calibri" pitchFamily="34" charset="-122"/>
+                <a:cs typeface="Calibri" pitchFamily="34" charset="-120"/>
+              </a:rPr>
+              <a:t>9</a:t>
+            </a:r>
+            <a:r>
+              <a:rPr lang="ko-KR" altLang="en-US" sz="1200" dirty="0">
+                <a:solidFill>
+                  <a:srgbClr val="4A4E5A"/>
+                </a:solidFill>
+                <a:latin typeface="Calibri" pitchFamily="34" charset="0"/>
+                <a:ea typeface="Calibri" pitchFamily="34" charset="-122"/>
+                <a:cs typeface="Calibri" pitchFamily="34" charset="-120"/>
+              </a:rPr>
+              <a:t>명</a:t>
+            </a:r>
+            <a:r>
+              <a:rPr lang="en-US" altLang="ko-KR" sz="1200" dirty="0">
+                <a:solidFill>
+                  <a:srgbClr val="4A4E5A"/>
+                </a:solidFill>
+                <a:latin typeface="Calibri" pitchFamily="34" charset="0"/>
+                <a:ea typeface="Calibri" pitchFamily="34" charset="-122"/>
+                <a:cs typeface="Calibri" pitchFamily="34" charset="-120"/>
+              </a:rPr>
+              <a:t>, </a:t>
+            </a:r>
+            <a:r>
+              <a:rPr lang="en-US" sz="1200" dirty="0">
+                <a:solidFill>
+                  <a:srgbClr val="4A4E5A"/>
+                </a:solidFill>
+                <a:latin typeface="Calibri" pitchFamily="34" charset="0"/>
+                <a:ea typeface="Calibri" pitchFamily="34" charset="-122"/>
+                <a:cs typeface="Calibri" pitchFamily="34" charset="-120"/>
+              </a:rPr>
+              <a:t>총 18명을 대상으로 진행했습니다.</a:t>
             </a:r>
             <a:endParaRPr lang="en-US" sz="1200" dirty="0"/>
           </a:p>
@@ -2969,7 +3076,7 @@
                 <a:ea typeface="Calibri" pitchFamily="34" charset="-122"/>
                 <a:cs typeface="Calibri" pitchFamily="34" charset="-120"/>
               </a:rPr>
-              <a:t> 19명이며, 이 중 유의미한 응답을 준 12명을 기준으로 정리했습니다)</a:t>
+              <a:t> 18명이며, 이 중 유의미한 응답을 준 9명을 기준으로 정리했습니다)</a:t>
             </a:r>
             <a:endParaRPr lang="en-US" sz="1050" dirty="0"/>
           </a:p>
@@ -3052,7 +3159,7 @@
                 <a:ea typeface="Calibri" pitchFamily="34" charset="-122"/>
                 <a:cs typeface="Calibri" pitchFamily="34" charset="-120"/>
               </a:rPr>
-              <a:t>7 / 12</a:t>
+              <a:t>7 / 9</a:t>
             </a:r>
             <a:endParaRPr lang="en-US" sz="1350" dirty="0"/>
           </a:p>
@@ -3219,7 +3326,7 @@
                 <a:ea typeface="Calibri" pitchFamily="34" charset="-122"/>
                 <a:cs typeface="Calibri" pitchFamily="34" charset="-120"/>
               </a:rPr>
-              <a:t>8 / 12</a:t>
+              <a:t>8 / 9</a:t>
             </a:r>
             <a:endParaRPr lang="en-US" sz="1350" dirty="0"/>
           </a:p>
@@ -3406,7 +3513,40 @@
                 <a:ea typeface="Calibri" pitchFamily="34" charset="-122"/>
                 <a:cs typeface="Calibri" pitchFamily="34" charset="-120"/>
               </a:rPr>
-              <a:t>질문 대상 11명 중 10명이 '유사하지 않다'고 답했고(색감이 급구의 파란색과 다름 · 리스트형 UI는 일반적 형태로 인식), 1명만 '전체적으로 비슷하다'는 인상을 받았습니다. (나머지 1명은 급구를 알지 못해 질문에서 제외)</a:t>
+              <a:t>질문 대상 11명 중 10명이 '유사하지 않다'고 답했고(색감이 급구의 파란색과 다름 · 리스트형 UI는 일반적 형태로 인식), 1명만 '전체적으로 비슷하다'는 </a:t>
+            </a:r>
+            <a:r>
+              <a:rPr lang="en-US" sz="1150" dirty="0" err="1">
+                <a:solidFill>
+                  <a:srgbClr val="4A4E5A"/>
+                </a:solidFill>
+                <a:latin typeface="Calibri" pitchFamily="34" charset="0"/>
+                <a:ea typeface="Calibri" pitchFamily="34" charset="-122"/>
+                <a:cs typeface="Calibri" pitchFamily="34" charset="-120"/>
+              </a:rPr>
+              <a:t>인상을</a:t>
+            </a:r>
+            <a:r>
+              <a:rPr lang="en-US" sz="1150" dirty="0">
+                <a:solidFill>
+                  <a:srgbClr val="4A4E5A"/>
+                </a:solidFill>
+                <a:latin typeface="Calibri" pitchFamily="34" charset="0"/>
+                <a:ea typeface="Calibri" pitchFamily="34" charset="-122"/>
+                <a:cs typeface="Calibri" pitchFamily="34" charset="-120"/>
+              </a:rPr>
+              <a:t> </a:t>
+            </a:r>
+            <a:r>
+              <a:rPr lang="en-US" sz="1150" dirty="0" err="1">
+                <a:solidFill>
+                  <a:srgbClr val="4A4E5A"/>
+                </a:solidFill>
+                <a:latin typeface="Calibri" pitchFamily="34" charset="0"/>
+                <a:ea typeface="Calibri" pitchFamily="34" charset="-122"/>
+                <a:cs typeface="Calibri" pitchFamily="34" charset="-120"/>
+              </a:rPr>
+              <a:t>받았습니다</a:t>
             </a:r>
             <a:endParaRPr lang="en-US" sz="1150" dirty="0"/>
           </a:p>
@@ -3448,7 +3588,73 @@
                 <a:ea typeface="Calibri" pitchFamily="34" charset="-122"/>
                 <a:cs typeface="Calibri" pitchFamily="34" charset="-120"/>
               </a:rPr>
-              <a:t>유의할 점: 급구 경험자 1명은 화면이 다소 복잡하다는 의견을, 당근 경험자 1명은 실제 지원 여부는 서비스 인지도에 달려 있다는 의견을 주셨습니다.</a:t>
+              <a:t>유의할 점: </a:t>
+            </a:r>
+            <a:r>
+              <a:rPr lang="en-US" sz="1150" i="1" dirty="0" err="1">
+                <a:solidFill>
+                  <a:srgbClr val="8A8FA3"/>
+                </a:solidFill>
+                <a:latin typeface="Calibri" pitchFamily="34" charset="0"/>
+                <a:ea typeface="Calibri" pitchFamily="34" charset="-122"/>
+                <a:cs typeface="Calibri" pitchFamily="34" charset="-120"/>
+              </a:rPr>
+              <a:t>급구</a:t>
+            </a:r>
+            <a:r>
+              <a:rPr lang="ko-KR" altLang="en-US" sz="1150" i="1" dirty="0">
+                <a:solidFill>
+                  <a:srgbClr val="8A8FA3"/>
+                </a:solidFill>
+                <a:latin typeface="Calibri" pitchFamily="34" charset="0"/>
+                <a:ea typeface="Calibri" pitchFamily="34" charset="-122"/>
+                <a:cs typeface="Calibri" pitchFamily="34" charset="-120"/>
+              </a:rPr>
+              <a:t>러</a:t>
+            </a:r>
+            <a:r>
+              <a:rPr lang="en-US" sz="1150" i="1" dirty="0">
+                <a:solidFill>
+                  <a:srgbClr val="8A8FA3"/>
+                </a:solidFill>
+                <a:latin typeface="Calibri" pitchFamily="34" charset="0"/>
+                <a:ea typeface="Calibri" pitchFamily="34" charset="-122"/>
+                <a:cs typeface="Calibri" pitchFamily="34" charset="-120"/>
+              </a:rPr>
+              <a:t> 1명은 화면이 다소 복잡하다는 의견을, </a:t>
+            </a:r>
+            <a:r>
+              <a:rPr lang="en-US" sz="1150" i="1" dirty="0" err="1">
+                <a:solidFill>
+                  <a:srgbClr val="8A8FA3"/>
+                </a:solidFill>
+                <a:latin typeface="Calibri" pitchFamily="34" charset="0"/>
+                <a:ea typeface="Calibri" pitchFamily="34" charset="-122"/>
+                <a:cs typeface="Calibri" pitchFamily="34" charset="-120"/>
+              </a:rPr>
+              <a:t>당근</a:t>
+            </a:r>
+            <a:r>
+              <a:rPr lang="ko-KR" altLang="en-US" sz="1150" i="1" dirty="0">
+                <a:solidFill>
+                  <a:srgbClr val="8A8FA3"/>
+                </a:solidFill>
+                <a:latin typeface="Calibri" pitchFamily="34" charset="0"/>
+                <a:ea typeface="Calibri" pitchFamily="34" charset="-122"/>
+                <a:cs typeface="Calibri" pitchFamily="34" charset="-120"/>
+              </a:rPr>
+              <a:t>러</a:t>
+            </a:r>
+            <a:r>
+              <a:rPr lang="en-US" sz="1150" i="1" dirty="0">
+                <a:solidFill>
+                  <a:srgbClr val="8A8FA3"/>
+                </a:solidFill>
+                <a:latin typeface="Calibri" pitchFamily="34" charset="0"/>
+                <a:ea typeface="Calibri" pitchFamily="34" charset="-122"/>
+                <a:cs typeface="Calibri" pitchFamily="34" charset="-120"/>
+              </a:rPr>
+              <a:t> 1명은 실제 지원 여부는 서비스 인지도에 달려 있다는 의견을 주셨습니다.</a:t>
             </a:r>
             <a:endParaRPr lang="en-US" sz="1150" dirty="0"/>
           </a:p>
@@ -3939,26 +4145,6 @@
           </a:p>
         </p:txBody>
       </p:sp>
-      <p:sp>
-        <p:nvSpPr>
-          <p:cNvPr id="13" name="Shape 8"/>
-          <p:cNvSpPr/>
-          <p:nvPr/>
-        </p:nvSpPr>
-        <p:spPr>
-          <a:xfrm>
-            <a:off x="8252490" y="3753612"/>
-            <a:ext cx="146304" cy="219456"/>
-          </a:xfrm>
-          <a:prstGeom prst="rightArrow">
-            <a:avLst/>
-          </a:prstGeom>
-          <a:solidFill>
-            <a:srgbClr val="B9C4C2"/>
-          </a:solidFill>
-          <a:ln/>
-        </p:spPr>
-      </p:sp>
       <p:pic>
         <p:nvPicPr>
           <p:cNvPr id="14" name="Image 3" descr="/mnt/user-data/uploads/위매칭_채용완료화면_case1.jpg"/>
@@ -3975,7 +4161,7 @@
         </p:blipFill>
         <p:spPr>
           <a:xfrm>
-            <a:off x="8407938" y="1783080"/>
+            <a:off x="9407938" y="1783080"/>
             <a:ext cx="2066574" cy="4160520"/>
           </a:xfrm>
           <a:prstGeom prst="rect">
@@ -3991,7 +4177,7 @@
         </p:nvSpPr>
         <p:spPr>
           <a:xfrm>
-            <a:off x="8407938" y="6016752"/>
+            <a:off x="9407938" y="6016752"/>
             <a:ext cx="2066574" cy="274320"/>
           </a:xfrm>
           <a:prstGeom prst="rect">
@@ -4058,6 +4244,86 @@
               <a:t>4</a:t>
             </a:r>
             <a:endParaRPr lang="en-US" sz="1100" dirty="0"/>
+          </a:p>
+        </p:txBody>
+      </p:sp>
+      <p:cxnSp>
+        <p:nvCxnSpPr>
+          <p:cNvPr id="9001" name="HireDecisionArrow"/>
+          <p:cNvCxnSpPr/>
+          <p:nvPr/>
+        </p:nvCxnSpPr>
+        <p:spPr>
+          <a:xfrm>
+            <a:off x="8283346" y="3863340"/>
+            <a:ext cx="1084592" cy="0"/>
+          </a:xfrm>
+          <a:prstGeom prst="straightConnector1">
+            <a:avLst/>
+          </a:prstGeom>
+          <a:ln w="38100">
+            <a:solidFill>
+              <a:srgbClr val="245251"/>
+            </a:solidFill>
+            <a:tailEnd type="triangle" w="lg" len="lg"/>
+          </a:ln>
+        </p:spPr>
+        <p:style>
+          <a:lnRef idx="1">
+            <a:schemeClr val="accent1"/>
+          </a:lnRef>
+          <a:fillRef idx="0">
+            <a:schemeClr val="accent1"/>
+          </a:fillRef>
+          <a:effectRef idx="0">
+            <a:schemeClr val="accent1"/>
+          </a:effectRef>
+          <a:fontRef idx="minor">
+            <a:schemeClr val="tx1"/>
+          </a:fontRef>
+        </p:style>
+      </p:cxnSp>
+      <p:sp>
+        <p:nvSpPr>
+          <p:cNvPr id="9002" name="HireDecisionBox"/>
+          <p:cNvSpPr/>
+          <p:nvPr/>
+        </p:nvSpPr>
+        <p:spPr>
+          <a:xfrm>
+            <a:off x="8325642" y="3613340"/>
+            <a:ext cx="1000000" cy="500000"/>
+          </a:xfrm>
+          <a:prstGeom prst="roundRect">
+            <a:avLst>
+              <a:gd name="adj" fmla="val 10000"/>
+            </a:avLst>
+          </a:prstGeom>
+          <a:solidFill>
+            <a:srgbClr val="FFFFFF"/>
+          </a:solidFill>
+          <a:ln w="19050">
+            <a:prstDash val="dash"/>
+          </a:ln>
+        </p:spPr>
+        <p:txBody>
+          <a:bodyPr wrap="square" lIns="45720" tIns="27432" rIns="45720" bIns="27432" anchor="ctr">
+            <a:normAutofit fontScale="85000" lnSpcReduction="10000"/>
+          </a:bodyPr>
+          <a:lstStyle/>
+          <a:p>
+            <a:pPr algn="ctr"/>
+            <a:r>
+              <a:rPr lang="ko-KR" altLang="en-US" sz="1300" b="1" dirty="0">
+                <a:solidFill>
+                  <a:srgbClr val="245251"/>
+                </a:solidFill>
+                <a:latin typeface="Calibri" pitchFamily="34" charset="0"/>
+                <a:ea typeface="Calibri" pitchFamily="34" charset="-122"/>
+                <a:cs typeface="Calibri" pitchFamily="34" charset="-120"/>
+              </a:rPr>
+              <a:t>사업주 채용의사결정</a:t>
+            </a:r>
           </a:p>
         </p:txBody>
       </p:sp>
@@ -4573,26 +4839,6 @@
           </a:p>
         </p:txBody>
       </p:sp>
-      <p:sp>
-        <p:nvSpPr>
-          <p:cNvPr id="13" name="Shape 8"/>
-          <p:cNvSpPr/>
-          <p:nvPr/>
-        </p:nvSpPr>
-        <p:spPr>
-          <a:xfrm>
-            <a:off x="8252490" y="3753612"/>
-            <a:ext cx="146304" cy="219456"/>
-          </a:xfrm>
-          <a:prstGeom prst="rightArrow">
-            <a:avLst/>
-          </a:prstGeom>
-          <a:solidFill>
-            <a:srgbClr val="B9C4C2"/>
-          </a:solidFill>
-          <a:ln/>
-        </p:spPr>
-      </p:sp>
       <p:pic>
         <p:nvPicPr>
           <p:cNvPr id="14" name="Image 3" descr="/mnt/user-data/uploads/위매칭_채용완료화면_case2.jpg"/>
@@ -4609,7 +4855,7 @@
         </p:blipFill>
         <p:spPr>
           <a:xfrm>
-            <a:off x="8407938" y="1783080"/>
+            <a:off x="9407938" y="1783080"/>
             <a:ext cx="2066574" cy="4160520"/>
           </a:xfrm>
           <a:prstGeom prst="rect">
@@ -4625,7 +4871,7 @@
         </p:nvSpPr>
         <p:spPr>
           <a:xfrm>
-            <a:off x="8407938" y="6016752"/>
+            <a:off x="9407938" y="6016752"/>
             <a:ext cx="2066574" cy="274320"/>
           </a:xfrm>
           <a:prstGeom prst="rect">
@@ -4725,6 +4971,86 @@
           </a:prstGeom>
         </p:spPr>
       </p:pic>
+      <p:cxnSp>
+        <p:nvCxnSpPr>
+          <p:cNvPr id="9001" name="HireDecisionArrow"/>
+          <p:cNvCxnSpPr/>
+          <p:nvPr/>
+        </p:nvCxnSpPr>
+        <p:spPr>
+          <a:xfrm>
+            <a:off x="8283346" y="3863340"/>
+            <a:ext cx="1084592" cy="0"/>
+          </a:xfrm>
+          <a:prstGeom prst="straightConnector1">
+            <a:avLst/>
+          </a:prstGeom>
+          <a:ln w="38100">
+            <a:solidFill>
+              <a:srgbClr val="245251"/>
+            </a:solidFill>
+            <a:tailEnd type="triangle" w="lg" len="lg"/>
+          </a:ln>
+        </p:spPr>
+        <p:style>
+          <a:lnRef idx="1">
+            <a:schemeClr val="accent1"/>
+          </a:lnRef>
+          <a:fillRef idx="0">
+            <a:schemeClr val="accent1"/>
+          </a:fillRef>
+          <a:effectRef idx="0">
+            <a:schemeClr val="accent1"/>
+          </a:effectRef>
+          <a:fontRef idx="minor">
+            <a:schemeClr val="tx1"/>
+          </a:fontRef>
+        </p:style>
+      </p:cxnSp>
+      <p:sp>
+        <p:nvSpPr>
+          <p:cNvPr id="9002" name="HireDecisionBox"/>
+          <p:cNvSpPr/>
+          <p:nvPr/>
+        </p:nvSpPr>
+        <p:spPr>
+          <a:xfrm>
+            <a:off x="8325642" y="3613340"/>
+            <a:ext cx="1000000" cy="500000"/>
+          </a:xfrm>
+          <a:prstGeom prst="roundRect">
+            <a:avLst>
+              <a:gd name="adj" fmla="val 10000"/>
+            </a:avLst>
+          </a:prstGeom>
+          <a:solidFill>
+            <a:srgbClr val="FFFFFF"/>
+          </a:solidFill>
+          <a:ln w="19050">
+            <a:prstDash val="dash"/>
+          </a:ln>
+        </p:spPr>
+        <p:txBody>
+          <a:bodyPr wrap="square" lIns="45720" tIns="27432" rIns="45720" bIns="27432" anchor="ctr">
+            <a:normAutofit fontScale="85000" lnSpcReduction="10000"/>
+          </a:bodyPr>
+          <a:lstStyle/>
+          <a:p>
+            <a:pPr algn="ctr"/>
+            <a:r>
+              <a:rPr lang="ko-KR" altLang="en-US" sz="1300" b="1" dirty="0">
+                <a:solidFill>
+                  <a:srgbClr val="245251"/>
+                </a:solidFill>
+                <a:latin typeface="Calibri" pitchFamily="34" charset="0"/>
+                <a:ea typeface="Calibri" pitchFamily="34" charset="-122"/>
+                <a:cs typeface="Calibri" pitchFamily="34" charset="-120"/>
+              </a:rPr>
+              <a:t>사업주 채용의사결정</a:t>
+            </a:r>
+          </a:p>
+        </p:txBody>
+      </p:sp>
     </p:spTree>
   </p:cSld>
   <p:clrMapOvr>

</xml_diff>